<commit_message>
docs: regenerate the final deck and its PDF from the same build
Stat cards read as fractions (9/12 -> 0/12, 7/8 -> 0/8, 393/393); the gantt header uses '/'
because the Korean font renders a backslash as the won sign.

Co-Authored-By: Claude Opus 5.5 <noreply@anthropic.com>
</commit_message>
<xml_diff>
--- a/docs/presentation/final/발표자료.pptx
+++ b/docs/presentation/final/발표자료.pptx
@@ -12003,7 +12003,7 @@
               </a:defRPr>
             </a:pPr>
             <a:r>
-              <a:t>공정 단계 \ 주차</a:t>
+              <a:t>공정 단계 / 주차</a:t>
             </a:r>
           </a:p>
         </p:txBody>
@@ -12986,7 +12986,7 @@
               </a:defRPr>
             </a:pPr>
             <a:r>
-              <a:t>9건 → 0건</a:t>
+              <a:t>9/12 → 0/12</a:t>
             </a:r>
           </a:p>
           <a:p>
@@ -13002,7 +13002,7 @@
               </a:defRPr>
             </a:pPr>
             <a:r>
-              <a:t>LAB 공격 12건 · 유출 (OFF → ON)</a:t>
+              <a:t>LAB 공격 12건 중 유출된 건수 (OFF → ON)</a:t>
             </a:r>
           </a:p>
           <a:p>
@@ -13101,7 +13101,7 @@
               </a:defRPr>
             </a:pPr>
             <a:r>
-              <a:t>7건 → 0건</a:t>
+              <a:t>7/8 → 0/8</a:t>
             </a:r>
           </a:p>
           <a:p>
@@ -13117,7 +13117,7 @@
               </a:defRPr>
             </a:pPr>
             <a:r>
-              <a:t>출력 단계 공격 8건 · 노출 (OFF → ON)</a:t>
+              <a:t>출력 단계 공격 8건 중 노출된 건수 (OFF → ON)</a:t>
             </a:r>
           </a:p>
           <a:p>
@@ -13216,7 +13216,7 @@
               </a:defRPr>
             </a:pPr>
             <a:r>
-              <a:t>393건 / 393건</a:t>
+              <a:t>393/393</a:t>
             </a:r>
           </a:p>
           <a:p>
@@ -13232,7 +13232,7 @@
               </a:defRPr>
             </a:pPr>
             <a:r>
-              <a:t>통합 시험 통과 (pytest)</a:t>
+              <a:t>통합 시험 393건 중 통과한 건수 (pytest)</a:t>
             </a:r>
           </a:p>
           <a:p>

</xml_diff>